<commit_message>
Refine presentation cover layout
</commit_message>
<xml_diff>
--- a/presentation/pnp_pinn_current_inference_presentation.pptx
+++ b/presentation/pnp_pinn_current_inference_presentation.pptx
@@ -1919,412 +1919,622 @@
       <p:grpSpPr>
         <a:xfrm xmlns:a="http://schemas.openxmlformats.org/drawingml/2006/main"/>
       </p:grpSpPr>
-      <p:sp>
-        <p:nvSpPr>
-          <p:cNvPr id="1" name="">
-            <a:extLst xmlns:a="http://schemas.openxmlformats.org/drawingml/2006/main">
-              <a:ext uri="{FF2B5EF4-FFF2-40B4-BE49-F238E27FC236}">
-                <a16:creationId xmlns:a16="http://schemas.microsoft.com/office/drawing/2014/main" id="{B4D54500-79B5-4365-83B4-B5821F96BCB9}"/>
-              </a:ext>
-            </a:extLst>
-          </p:cNvPr>
-          <p:cNvSpPr>
-            <a:spLocks xmlns:a="http://schemas.openxmlformats.org/drawingml/2006/main" noGrp="1"/>
-          </p:cNvSpPr>
-          <p:nvPr/>
-        </p:nvSpPr>
-        <p:spPr>
-          <a:xfrm xmlns:a="http://schemas.openxmlformats.org/drawingml/2006/main">
+      <p:sp xmlns:a="http://schemas.openxmlformats.org/drawingml/2006/main">
+        <p:nvSpPr>
+          <p:cNvPr id="2" name="Rectangle 1"/>
+          <p:cNvSpPr/>
+          <p:nvPr/>
+        </p:nvSpPr>
+        <p:spPr>
+          <a:xfrm>
             <a:off x="0" y="0"/>
             <a:ext cx="12192000" cy="6858000"/>
           </a:xfrm>
-          <a:prstGeom xmlns:a="http://schemas.openxmlformats.org/drawingml/2006/main" prst="rect">
-            <a:avLst/>
-          </a:prstGeom>
-          <a:solidFill xmlns:a="http://schemas.openxmlformats.org/drawingml/2006/main">
+          <a:prstGeom prst="rect">
+            <a:avLst/>
+          </a:prstGeom>
+          <a:solidFill>
             <a:srgbClr val="FBFAF7"/>
           </a:solidFill>
-          <a:ln xmlns:a="http://schemas.openxmlformats.org/drawingml/2006/main" w="0">
-            <a:solidFill>
-              <a:srgbClr val="000000">
-                <a:alpha val="0"/>
-              </a:srgbClr>
-            </a:solidFill>
-            <a:prstDash val="solid"/>
-          </a:ln>
-        </p:spPr>
-      </p:sp>
-      <p:sp>
-        <p:nvSpPr>
-          <p:cNvPr id="2" name="">
-            <a:extLst xmlns:a="http://schemas.openxmlformats.org/drawingml/2006/main">
-              <a:ext uri="{FF2B5EF4-FFF2-40B4-BE49-F238E27FC236}">
-                <a16:creationId xmlns:a16="http://schemas.microsoft.com/office/drawing/2014/main" id="{3A697213-76D0-4ABF-9EC9-9D9291C1FD38}"/>
-              </a:ext>
-            </a:extLst>
-          </p:cNvPr>
-          <p:cNvSpPr>
-            <a:spLocks xmlns:a="http://schemas.openxmlformats.org/drawingml/2006/main" noGrp="1"/>
-          </p:cNvSpPr>
-          <p:nvPr/>
-        </p:nvSpPr>
-        <p:spPr>
-          <a:xfrm xmlns:a="http://schemas.openxmlformats.org/drawingml/2006/main">
-            <a:off x="685800" y="704850"/>
-            <a:ext cx="1714500" cy="28575"/>
-          </a:xfrm>
-          <a:prstGeom xmlns:a="http://schemas.openxmlformats.org/drawingml/2006/main" prst="rect">
-            <a:avLst/>
-          </a:prstGeom>
-          <a:solidFill xmlns:a="http://schemas.openxmlformats.org/drawingml/2006/main">
+          <a:ln>
+            <a:noFill/>
+          </a:ln>
+        </p:spPr>
+        <p:style>
+          <a:lnRef idx="1">
+            <a:schemeClr val="accent1"/>
+          </a:lnRef>
+          <a:fillRef idx="3">
+            <a:schemeClr val="accent1"/>
+          </a:fillRef>
+          <a:effectRef idx="2">
+            <a:schemeClr val="accent1"/>
+          </a:effectRef>
+          <a:fontRef idx="minor">
+            <a:schemeClr val="lt1"/>
+          </a:fontRef>
+        </p:style>
+        <p:txBody>
+          <a:bodyPr rtlCol="0" anchor="ctr"/>
+          <a:lstStyle/>
+          <a:p>
+            <a:pPr algn="ctr"/>
+          </a:p>
+        </p:txBody>
+      </p:sp>
+      <p:sp xmlns:a="http://schemas.openxmlformats.org/drawingml/2006/main">
+        <p:nvSpPr>
+          <p:cNvPr id="3" name="TextBox 2"/>
+          <p:cNvSpPr txBox="1"/>
+          <p:nvPr/>
+        </p:nvSpPr>
+        <p:spPr>
+          <a:xfrm>
+            <a:off x="685800" y="411480"/>
+            <a:ext cx="2926080" cy="219456"/>
+          </a:xfrm>
+          <a:prstGeom prst="rect">
+            <a:avLst/>
+          </a:prstGeom>
+          <a:noFill/>
+        </p:spPr>
+        <p:txBody>
+          <a:bodyPr wrap="none" lIns="0" rIns="0" tIns="0" bIns="0">
+            <a:spAutoFit/>
+          </a:bodyPr>
+          <a:lstStyle/>
+          <a:p>
+            <a:r>
+              <a:rPr sz="1050" b="1">
+                <a:solidFill>
+                  <a:srgbClr val="6D6D6D"/>
+                </a:solidFill>
+                <a:latin typeface="Helvetica Neue"/>
+              </a:rPr>
+              <a:t>Academic presentation</a:t>
+            </a:r>
+          </a:p>
+        </p:txBody>
+      </p:sp>
+      <p:sp xmlns:a="http://schemas.openxmlformats.org/drawingml/2006/main">
+        <p:nvSpPr>
+          <p:cNvPr id="4" name="Rectangle 3"/>
+          <p:cNvSpPr/>
+          <p:nvPr/>
+        </p:nvSpPr>
+        <p:spPr>
+          <a:xfrm>
+            <a:off x="685800" y="713232"/>
+            <a:ext cx="1737360" cy="27432"/>
+          </a:xfrm>
+          <a:prstGeom prst="rect">
+            <a:avLst/>
+          </a:prstGeom>
+          <a:solidFill>
             <a:srgbClr val="008C95"/>
           </a:solidFill>
-          <a:ln xmlns:a="http://schemas.openxmlformats.org/drawingml/2006/main" w="0">
-            <a:solidFill>
-              <a:srgbClr val="000000">
-                <a:alpha val="0"/>
-              </a:srgbClr>
-            </a:solidFill>
-            <a:prstDash val="solid"/>
-          </a:ln>
-        </p:spPr>
-      </p:sp>
-      <p:sp>
-        <p:nvSpPr>
-          <p:cNvPr id="3" name="">
-            <a:extLst xmlns:a="http://schemas.openxmlformats.org/drawingml/2006/main">
-              <a:ext uri="{FF2B5EF4-FFF2-40B4-BE49-F238E27FC236}">
-                <a16:creationId xmlns:a16="http://schemas.microsoft.com/office/drawing/2014/main" id="{8C2CD9B3-98A2-47CA-8F4C-7391DFB930A5}"/>
-              </a:ext>
-            </a:extLst>
-          </p:cNvPr>
-          <p:cNvSpPr>
-            <a:spLocks xmlns:a="http://schemas.openxmlformats.org/drawingml/2006/main" noGrp="1"/>
-          </p:cNvSpPr>
-          <p:nvPr/>
-        </p:nvSpPr>
-        <p:spPr>
-          <a:xfrm xmlns:a="http://schemas.openxmlformats.org/drawingml/2006/main">
-            <a:off x="685800" y="400050"/>
-            <a:ext cx="3429000" cy="171450"/>
-          </a:xfrm>
-          <a:prstGeom xmlns:a="http://schemas.openxmlformats.org/drawingml/2006/main" prst="rect">
-            <a:avLst/>
-          </a:prstGeom>
-          <a:solidFill xmlns:a="http://schemas.openxmlformats.org/drawingml/2006/main">
-            <a:srgbClr val="000000">
-              <a:alpha val="0"/>
-            </a:srgbClr>
-          </a:solidFill>
-          <a:ln xmlns:a="http://schemas.openxmlformats.org/drawingml/2006/main" w="0">
-            <a:solidFill>
-              <a:srgbClr val="000000">
-                <a:alpha val="0"/>
-              </a:srgbClr>
-            </a:solidFill>
-            <a:prstDash val="solid"/>
-          </a:ln>
-        </p:spPr>
-        <p:txBody>
-          <a:bodyPr xmlns:a="http://schemas.openxmlformats.org/drawingml/2006/main" lIns="0" tIns="0" rIns="0" bIns="0" anchor="t"/>
-          <a:lstStyle xmlns:a="http://schemas.openxmlformats.org/drawingml/2006/main"/>
-          <a:p xmlns:a="http://schemas.openxmlformats.org/drawingml/2006/main">
-            <a:pPr algn="l">
-              <a:defRPr sz="825" b="1">
+          <a:ln>
+            <a:noFill/>
+          </a:ln>
+        </p:spPr>
+        <p:style>
+          <a:lnRef idx="1">
+            <a:schemeClr val="accent1"/>
+          </a:lnRef>
+          <a:fillRef idx="3">
+            <a:schemeClr val="accent1"/>
+          </a:fillRef>
+          <a:effectRef idx="2">
+            <a:schemeClr val="accent1"/>
+          </a:effectRef>
+          <a:fontRef idx="minor">
+            <a:schemeClr val="lt1"/>
+          </a:fontRef>
+        </p:style>
+        <p:txBody>
+          <a:bodyPr rtlCol="0" anchor="ctr"/>
+          <a:lstStyle/>
+          <a:p>
+            <a:pPr algn="ctr"/>
+          </a:p>
+        </p:txBody>
+      </p:sp>
+      <p:sp xmlns:a="http://schemas.openxmlformats.org/drawingml/2006/main">
+        <p:nvSpPr>
+          <p:cNvPr id="5" name="TextBox 4"/>
+          <p:cNvSpPr txBox="1"/>
+          <p:nvPr/>
+        </p:nvSpPr>
+        <p:spPr>
+          <a:xfrm>
+            <a:off x="685800" y="1325880"/>
+            <a:ext cx="6812280" cy="1143000"/>
+          </a:xfrm>
+          <a:prstGeom prst="rect">
+            <a:avLst/>
+          </a:prstGeom>
+          <a:noFill/>
+        </p:spPr>
+        <p:txBody>
+          <a:bodyPr wrap="none" lIns="0" rIns="0" tIns="0" bIns="0">
+            <a:spAutoFit/>
+          </a:bodyPr>
+          <a:lstStyle/>
+          <a:p>
+            <a:r>
+              <a:rPr sz="3100" b="1">
+                <a:solidFill>
+                  <a:srgbClr val="151515"/>
+                </a:solidFill>
+                <a:latin typeface="Helvetica Neue"/>
+              </a:rPr>
+              <a:t>Current-Based Inverse Inference
+for a 1D Poisson-Nernst-Planck System</a:t>
+            </a:r>
+          </a:p>
+        </p:txBody>
+      </p:sp>
+      <p:sp xmlns:a="http://schemas.openxmlformats.org/drawingml/2006/main">
+        <p:nvSpPr>
+          <p:cNvPr id="6" name="TextBox 5"/>
+          <p:cNvSpPr txBox="1"/>
+          <p:nvPr/>
+        </p:nvSpPr>
+        <p:spPr>
+          <a:xfrm>
+            <a:off x="713232" y="2788920"/>
+            <a:ext cx="6720840" cy="320040"/>
+          </a:xfrm>
+          <a:prstGeom prst="rect">
+            <a:avLst/>
+          </a:prstGeom>
+          <a:noFill/>
+        </p:spPr>
+        <p:txBody>
+          <a:bodyPr wrap="none" lIns="0" rIns="0" tIns="0" bIns="0">
+            <a:spAutoFit/>
+          </a:bodyPr>
+          <a:lstStyle/>
+          <a:p>
+            <a:r>
+              <a:rPr sz="1700" b="0">
                 <a:solidFill>
                   <a:srgbClr val="6D6D6D"/>
                 </a:solidFill>
-                <a:latin typeface="Aptos"/>
-                <a:ea typeface="Aptos"/>
-                <a:cs typeface="Aptos"/>
-              </a:defRPr>
-            </a:pPr>
-            <a:r>
-              <a:rPr sz="825" b="1">
+                <a:latin typeface="Helvetica Neue"/>
+              </a:rPr>
+              <a:t>A physics-informed neural-network surrogate for diffusion-parameter inference</a:t>
+            </a:r>
+          </a:p>
+        </p:txBody>
+      </p:sp>
+      <p:sp xmlns:a="http://schemas.openxmlformats.org/drawingml/2006/main">
+        <p:nvSpPr>
+          <p:cNvPr id="7" name="Rectangle 6"/>
+          <p:cNvSpPr/>
+          <p:nvPr/>
+        </p:nvSpPr>
+        <p:spPr>
+          <a:xfrm>
+            <a:off x="7909560" y="1261872"/>
+            <a:ext cx="3154680" cy="2880360"/>
+          </a:xfrm>
+          <a:prstGeom prst="rect">
+            <a:avLst/>
+          </a:prstGeom>
+          <a:solidFill>
+            <a:srgbClr val="FFFFFF"/>
+          </a:solidFill>
+          <a:ln w="11430">
+            <a:solidFill>
+              <a:srgbClr val="008C95"/>
+            </a:solidFill>
+          </a:ln>
+        </p:spPr>
+        <p:style>
+          <a:lnRef idx="1">
+            <a:schemeClr val="accent1"/>
+          </a:lnRef>
+          <a:fillRef idx="3">
+            <a:schemeClr val="accent1"/>
+          </a:fillRef>
+          <a:effectRef idx="2">
+            <a:schemeClr val="accent1"/>
+          </a:effectRef>
+          <a:fontRef idx="minor">
+            <a:schemeClr val="lt1"/>
+          </a:fontRef>
+        </p:style>
+        <p:txBody>
+          <a:bodyPr rtlCol="0" anchor="ctr"/>
+          <a:lstStyle/>
+          <a:p>
+            <a:pPr algn="ctr"/>
+          </a:p>
+        </p:txBody>
+      </p:sp>
+      <p:sp xmlns:a="http://schemas.openxmlformats.org/drawingml/2006/main">
+        <p:nvSpPr>
+          <p:cNvPr id="8" name="Rectangle 7"/>
+          <p:cNvSpPr/>
+          <p:nvPr/>
+        </p:nvSpPr>
+        <p:spPr>
+          <a:xfrm>
+            <a:off x="7909560" y="1261872"/>
+            <a:ext cx="3154680" cy="32004"/>
+          </a:xfrm>
+          <a:prstGeom prst="rect">
+            <a:avLst/>
+          </a:prstGeom>
+          <a:solidFill>
+            <a:srgbClr val="008C95"/>
+          </a:solidFill>
+          <a:ln>
+            <a:noFill/>
+          </a:ln>
+        </p:spPr>
+        <p:style>
+          <a:lnRef idx="1">
+            <a:schemeClr val="accent1"/>
+          </a:lnRef>
+          <a:fillRef idx="3">
+            <a:schemeClr val="accent1"/>
+          </a:fillRef>
+          <a:effectRef idx="2">
+            <a:schemeClr val="accent1"/>
+          </a:effectRef>
+          <a:fontRef idx="minor">
+            <a:schemeClr val="lt1"/>
+          </a:fontRef>
+        </p:style>
+        <p:txBody>
+          <a:bodyPr rtlCol="0" anchor="ctr"/>
+          <a:lstStyle/>
+          <a:p>
+            <a:pPr algn="ctr"/>
+          </a:p>
+        </p:txBody>
+      </p:sp>
+      <p:sp xmlns:a="http://schemas.openxmlformats.org/drawingml/2006/main">
+        <p:nvSpPr>
+          <p:cNvPr id="9" name="TextBox 8"/>
+          <p:cNvSpPr txBox="1"/>
+          <p:nvPr/>
+        </p:nvSpPr>
+        <p:spPr>
+          <a:xfrm>
+            <a:off x="8183879" y="1572768"/>
+            <a:ext cx="2103120" cy="219456"/>
+          </a:xfrm>
+          <a:prstGeom prst="rect">
+            <a:avLst/>
+          </a:prstGeom>
+          <a:noFill/>
+        </p:spPr>
+        <p:txBody>
+          <a:bodyPr wrap="none" lIns="0" rIns="0" tIns="0" bIns="0">
+            <a:spAutoFit/>
+          </a:bodyPr>
+          <a:lstStyle/>
+          <a:p>
+            <a:r>
+              <a:rPr sz="1200" b="1">
+                <a:solidFill>
+                  <a:srgbClr val="008C95"/>
+                </a:solidFill>
+                <a:latin typeface="Aptos"/>
+              </a:rPr>
+              <a:t>Research question</a:t>
+            </a:r>
+          </a:p>
+        </p:txBody>
+      </p:sp>
+      <p:sp xmlns:a="http://schemas.openxmlformats.org/drawingml/2006/main">
+        <p:nvSpPr>
+          <p:cNvPr id="10" name="TextBox 9"/>
+          <p:cNvSpPr txBox="1"/>
+          <p:nvPr/>
+        </p:nvSpPr>
+        <p:spPr>
+          <a:xfrm>
+            <a:off x="8183879" y="1920240"/>
+            <a:ext cx="2606040" cy="960120"/>
+          </a:xfrm>
+          <a:prstGeom prst="rect">
+            <a:avLst/>
+          </a:prstGeom>
+          <a:noFill/>
+        </p:spPr>
+        <p:txBody>
+          <a:bodyPr wrap="none" lIns="0" rIns="0" tIns="0" bIns="0">
+            <a:spAutoFit/>
+          </a:bodyPr>
+          <a:lstStyle/>
+          <a:p>
+            <a:r>
+              <a:rPr sz="2400" b="1">
+                <a:solidFill>
+                  <a:srgbClr val="151515"/>
+                </a:solidFill>
+                <a:latin typeface="Helvetica Neue"/>
+              </a:rPr>
+              <a:t>Can electrode
+current identify
+Dp and Dn?</a:t>
+            </a:r>
+          </a:p>
+        </p:txBody>
+      </p:sp>
+      <p:sp xmlns:a="http://schemas.openxmlformats.org/drawingml/2006/main">
+        <p:nvSpPr>
+          <p:cNvPr id="11" name="TextBox 10"/>
+          <p:cNvSpPr txBox="1"/>
+          <p:nvPr/>
+        </p:nvSpPr>
+        <p:spPr>
+          <a:xfrm>
+            <a:off x="8183879" y="3182112"/>
+            <a:ext cx="1143000" cy="201168"/>
+          </a:xfrm>
+          <a:prstGeom prst="rect">
+            <a:avLst/>
+          </a:prstGeom>
+          <a:noFill/>
+        </p:spPr>
+        <p:txBody>
+          <a:bodyPr wrap="none" lIns="0" rIns="0" tIns="0" bIns="0">
+            <a:spAutoFit/>
+          </a:bodyPr>
+          <a:lstStyle/>
+          <a:p>
+            <a:r>
+              <a:rPr sz="1050" b="1">
+                <a:solidFill>
+                  <a:srgbClr val="D05A2A"/>
+                </a:solidFill>
+                <a:latin typeface="Helvetica Neue"/>
+              </a:rPr>
+              <a:t>observation</a:t>
+            </a:r>
+          </a:p>
+        </p:txBody>
+      </p:sp>
+      <p:sp xmlns:a="http://schemas.openxmlformats.org/drawingml/2006/main">
+        <p:nvSpPr>
+          <p:cNvPr id="12" name="TextBox 11"/>
+          <p:cNvSpPr txBox="1"/>
+          <p:nvPr/>
+        </p:nvSpPr>
+        <p:spPr>
+          <a:xfrm>
+            <a:off x="8183879" y="3438144"/>
+            <a:ext cx="731520" cy="228600"/>
+          </a:xfrm>
+          <a:prstGeom prst="rect">
+            <a:avLst/>
+          </a:prstGeom>
+          <a:noFill/>
+        </p:spPr>
+        <p:txBody>
+          <a:bodyPr wrap="none" lIns="0" rIns="0" tIns="0" bIns="0">
+            <a:spAutoFit/>
+          </a:bodyPr>
+          <a:lstStyle/>
+          <a:p>
+            <a:r>
+              <a:rPr sz="1800" b="1">
+                <a:solidFill>
+                  <a:srgbClr val="D05A2A"/>
+                </a:solidFill>
+                <a:latin typeface="Helvetica Neue"/>
+              </a:rPr>
+              <a:t>I(t)</a:t>
+            </a:r>
+          </a:p>
+        </p:txBody>
+      </p:sp>
+      <p:cxnSp xmlns:a="http://schemas.openxmlformats.org/drawingml/2006/main">
+        <p:nvCxnSpPr>
+          <p:cNvPr id="13" name="Connector 12"/>
+          <p:cNvCxnSpPr/>
+          <p:nvPr/>
+        </p:nvCxnSpPr>
+        <p:spPr>
+          <a:xfrm>
+            <a:off x="8979408" y="3547872"/>
+            <a:ext cx="566928" cy="0"/>
+          </a:xfrm>
+          <a:prstGeom prst="line">
+            <a:avLst/>
+          </a:prstGeom>
+          <a:ln w="16510">
+            <a:solidFill>
+              <a:srgbClr val="6D6D6D"/>
+            </a:solidFill>
+          </a:ln>
+        </p:spPr>
+        <p:style>
+          <a:lnRef idx="2">
+            <a:schemeClr val="accent1"/>
+          </a:lnRef>
+          <a:fillRef idx="0">
+            <a:schemeClr val="accent1"/>
+          </a:fillRef>
+          <a:effectRef idx="1">
+            <a:schemeClr val="accent1"/>
+          </a:effectRef>
+          <a:fontRef idx="minor">
+            <a:schemeClr val="tx1"/>
+          </a:fontRef>
+        </p:style>
+      </p:cxnSp>
+      <p:sp xmlns:a="http://schemas.openxmlformats.org/drawingml/2006/main">
+        <p:nvSpPr>
+          <p:cNvPr id="14" name="TextBox 13"/>
+          <p:cNvSpPr txBox="1"/>
+          <p:nvPr/>
+        </p:nvSpPr>
+        <p:spPr>
+          <a:xfrm>
+            <a:off x="9674352" y="3182112"/>
+            <a:ext cx="1051560" cy="201168"/>
+          </a:xfrm>
+          <a:prstGeom prst="rect">
+            <a:avLst/>
+          </a:prstGeom>
+          <a:noFill/>
+        </p:spPr>
+        <p:txBody>
+          <a:bodyPr wrap="none" lIns="0" rIns="0" tIns="0" bIns="0">
+            <a:spAutoFit/>
+          </a:bodyPr>
+          <a:lstStyle/>
+          <a:p>
+            <a:r>
+              <a:rPr sz="1050" b="1">
+                <a:solidFill>
+                  <a:srgbClr val="3F7D55"/>
+                </a:solidFill>
+                <a:latin typeface="Helvetica Neue"/>
+              </a:rPr>
+              <a:t>output</a:t>
+            </a:r>
+          </a:p>
+        </p:txBody>
+      </p:sp>
+      <p:sp xmlns:a="http://schemas.openxmlformats.org/drawingml/2006/main">
+        <p:nvSpPr>
+          <p:cNvPr id="15" name="TextBox 14"/>
+          <p:cNvSpPr txBox="1"/>
+          <p:nvPr/>
+        </p:nvSpPr>
+        <p:spPr>
+          <a:xfrm>
+            <a:off x="9674352" y="3438144"/>
+            <a:ext cx="1188720" cy="457200"/>
+          </a:xfrm>
+          <a:prstGeom prst="rect">
+            <a:avLst/>
+          </a:prstGeom>
+          <a:noFill/>
+        </p:spPr>
+        <p:txBody>
+          <a:bodyPr wrap="none" lIns="0" rIns="0" tIns="0" bIns="0">
+            <a:spAutoFit/>
+          </a:bodyPr>
+          <a:lstStyle/>
+          <a:p>
+            <a:r>
+              <a:rPr sz="1500" b="1">
+                <a:solidFill>
+                  <a:srgbClr val="3F7D55"/>
+                </a:solidFill>
+                <a:latin typeface="Helvetica Neue"/>
+              </a:rPr>
+              <a:t>posterior over
+Dp, Dn</a:t>
+            </a:r>
+          </a:p>
+        </p:txBody>
+      </p:sp>
+      <p:sp xmlns:a="http://schemas.openxmlformats.org/drawingml/2006/main">
+        <p:nvSpPr>
+          <p:cNvPr id="16" name="TextBox 15"/>
+          <p:cNvSpPr txBox="1"/>
+          <p:nvPr/>
+        </p:nvSpPr>
+        <p:spPr>
+          <a:xfrm>
+            <a:off x="713232" y="4498848"/>
+            <a:ext cx="6492240" cy="502920"/>
+          </a:xfrm>
+          <a:prstGeom prst="rect">
+            <a:avLst/>
+          </a:prstGeom>
+          <a:noFill/>
+        </p:spPr>
+        <p:txBody>
+          <a:bodyPr wrap="none" lIns="0" rIns="0" tIns="0" bIns="0">
+            <a:spAutoFit/>
+          </a:bodyPr>
+          <a:lstStyle/>
+          <a:p>
+            <a:r>
+              <a:rPr sz="1400" b="0">
                 <a:solidFill>
                   <a:srgbClr val="6D6D6D"/>
                 </a:solidFill>
-                <a:latin typeface="Aptos"/>
-                <a:ea typeface="Aptos"/>
-                <a:cs typeface="Aptos"/>
-              </a:rPr>
-              <a:t>Academic presentation</a:t>
-            </a:r>
-          </a:p>
-        </p:txBody>
-      </p:sp>
-      <p:sp>
-        <p:nvSpPr>
-          <p:cNvPr id="4" name="">
-            <a:extLst xmlns:a="http://schemas.openxmlformats.org/drawingml/2006/main">
-              <a:ext uri="{FF2B5EF4-FFF2-40B4-BE49-F238E27FC236}">
-                <a16:creationId xmlns:a16="http://schemas.microsoft.com/office/drawing/2014/main" id="{A89D2A87-91F2-4AA6-97E1-8EAF8406B392}"/>
-              </a:ext>
-            </a:extLst>
-          </p:cNvPr>
-          <p:cNvSpPr>
-            <a:spLocks xmlns:a="http://schemas.openxmlformats.org/drawingml/2006/main" noGrp="1"/>
-          </p:cNvSpPr>
-          <p:nvPr/>
-        </p:nvSpPr>
-        <p:spPr>
-          <a:xfrm xmlns:a="http://schemas.openxmlformats.org/drawingml/2006/main">
-            <a:off x="685800" y="1257300"/>
-            <a:ext cx="9906000" cy="1257300"/>
-          </a:xfrm>
-          <a:prstGeom xmlns:a="http://schemas.openxmlformats.org/drawingml/2006/main" prst="rect">
-            <a:avLst/>
-          </a:prstGeom>
-          <a:solidFill xmlns:a="http://schemas.openxmlformats.org/drawingml/2006/main">
-            <a:srgbClr val="000000">
-              <a:alpha val="0"/>
-            </a:srgbClr>
-          </a:solidFill>
-          <a:ln xmlns:a="http://schemas.openxmlformats.org/drawingml/2006/main" w="0">
-            <a:solidFill>
-              <a:srgbClr val="000000">
-                <a:alpha val="0"/>
-              </a:srgbClr>
-            </a:solidFill>
-            <a:prstDash val="solid"/>
-          </a:ln>
-        </p:spPr>
-        <p:txBody>
-          <a:bodyPr xmlns:a="http://schemas.openxmlformats.org/drawingml/2006/main" lIns="0" tIns="0" rIns="0" bIns="0" anchor="t"/>
-          <a:lstStyle xmlns:a="http://schemas.openxmlformats.org/drawingml/2006/main"/>
-          <a:p xmlns:a="http://schemas.openxmlformats.org/drawingml/2006/main">
-            <a:pPr algn="l">
-              <a:defRPr sz="2925" b="1">
-                <a:solidFill>
-                  <a:srgbClr val="151515"/>
-                </a:solidFill>
-                <a:latin typeface="Aptos Display"/>
-                <a:ea typeface="Aptos Display"/>
-                <a:cs typeface="Aptos Display"/>
-              </a:defRPr>
-            </a:pPr>
-            <a:r>
-              <a:rPr sz="2925" b="1">
-                <a:solidFill>
-                  <a:srgbClr val="151515"/>
-                </a:solidFill>
-                <a:latin typeface="Aptos Display"/>
-                <a:ea typeface="Aptos Display"/>
-                <a:cs typeface="Aptos Display"/>
-              </a:rPr>
-              <a:t>Current-Based Inverse Inference for a 1D Poisson-Nernst-Planck System</a:t>
-            </a:r>
-          </a:p>
-        </p:txBody>
-      </p:sp>
-      <p:sp>
-        <p:nvSpPr>
-          <p:cNvPr id="5" name="">
-            <a:extLst xmlns:a="http://schemas.openxmlformats.org/drawingml/2006/main">
-              <a:ext uri="{FF2B5EF4-FFF2-40B4-BE49-F238E27FC236}">
-                <a16:creationId xmlns:a16="http://schemas.microsoft.com/office/drawing/2014/main" id="{E545157B-6B2E-4C1D-997A-8DCE5941D65F}"/>
-              </a:ext>
-            </a:extLst>
-          </p:cNvPr>
-          <p:cNvSpPr>
-            <a:spLocks xmlns:a="http://schemas.openxmlformats.org/drawingml/2006/main" noGrp="1"/>
-          </p:cNvSpPr>
-          <p:nvPr/>
-        </p:nvSpPr>
-        <p:spPr>
-          <a:xfrm xmlns:a="http://schemas.openxmlformats.org/drawingml/2006/main">
-            <a:off x="704850" y="2724150"/>
-            <a:ext cx="8572500" cy="361950"/>
-          </a:xfrm>
-          <a:prstGeom xmlns:a="http://schemas.openxmlformats.org/drawingml/2006/main" prst="rect">
-            <a:avLst/>
-          </a:prstGeom>
-          <a:solidFill xmlns:a="http://schemas.openxmlformats.org/drawingml/2006/main">
-            <a:srgbClr val="000000">
-              <a:alpha val="0"/>
-            </a:srgbClr>
-          </a:solidFill>
-          <a:ln xmlns:a="http://schemas.openxmlformats.org/drawingml/2006/main" w="0">
-            <a:solidFill>
-              <a:srgbClr val="000000">
-                <a:alpha val="0"/>
-              </a:srgbClr>
-            </a:solidFill>
-            <a:prstDash val="solid"/>
-          </a:ln>
-        </p:spPr>
-        <p:txBody>
-          <a:bodyPr xmlns:a="http://schemas.openxmlformats.org/drawingml/2006/main" lIns="0" tIns="0" rIns="0" bIns="0" anchor="t"/>
-          <a:lstStyle xmlns:a="http://schemas.openxmlformats.org/drawingml/2006/main"/>
-          <a:p xmlns:a="http://schemas.openxmlformats.org/drawingml/2006/main">
-            <a:pPr algn="l">
-              <a:defRPr sz="1500" b="0">
+                <a:latin typeface="Helvetica Neue"/>
+              </a:rPr>
+              <a:t>Measurable current -&gt; posterior uncertainty over diffusion parameters.</a:t>
+            </a:r>
+          </a:p>
+        </p:txBody>
+      </p:sp>
+      <p:sp xmlns:a="http://schemas.openxmlformats.org/drawingml/2006/main">
+        <p:nvSpPr>
+          <p:cNvPr id="17" name="TextBox 16"/>
+          <p:cNvSpPr txBox="1"/>
+          <p:nvPr/>
+        </p:nvSpPr>
+        <p:spPr>
+          <a:xfrm>
+            <a:off x="685800" y="5989320"/>
+            <a:ext cx="3108960" cy="201168"/>
+          </a:xfrm>
+          <a:prstGeom prst="rect">
+            <a:avLst/>
+          </a:prstGeom>
+          <a:noFill/>
+        </p:spPr>
+        <p:txBody>
+          <a:bodyPr wrap="none" lIns="0" rIns="0" tIns="0" bIns="0">
+            <a:spAutoFit/>
+          </a:bodyPr>
+          <a:lstStyle/>
+          <a:p>
+            <a:r>
+              <a:rPr sz="1150" b="0">
                 <a:solidFill>
                   <a:srgbClr val="6D6D6D"/>
                 </a:solidFill>
-                <a:latin typeface="Aptos"/>
-                <a:ea typeface="Aptos"/>
-                <a:cs typeface="Aptos"/>
-              </a:defRPr>
-            </a:pPr>
-            <a:r>
-              <a:rPr sz="1500" b="0">
+                <a:latin typeface="Helvetica Neue"/>
+              </a:rPr>
+              <a:t>Jack Jia | June 2026</a:t>
+            </a:r>
+          </a:p>
+        </p:txBody>
+      </p:sp>
+      <p:sp xmlns:a="http://schemas.openxmlformats.org/drawingml/2006/main">
+        <p:nvSpPr>
+          <p:cNvPr id="18" name="TextBox 17"/>
+          <p:cNvSpPr txBox="1"/>
+          <p:nvPr/>
+        </p:nvSpPr>
+        <p:spPr>
+          <a:xfrm>
+            <a:off x="7635240" y="5989320"/>
+            <a:ext cx="3429000" cy="201168"/>
+          </a:xfrm>
+          <a:prstGeom prst="rect">
+            <a:avLst/>
+          </a:prstGeom>
+          <a:noFill/>
+        </p:spPr>
+        <p:txBody>
+          <a:bodyPr wrap="none" lIns="0" rIns="0" tIns="0" bIns="0">
+            <a:spAutoFit/>
+          </a:bodyPr>
+          <a:lstStyle/>
+          <a:p>
+            <a:pPr algn="r"/>
+            <a:r>
+              <a:rPr sz="1150" b="0">
                 <a:solidFill>
                   <a:srgbClr val="6D6D6D"/>
                 </a:solidFill>
-                <a:latin typeface="Aptos"/>
-                <a:ea typeface="Aptos"/>
-                <a:cs typeface="Aptos"/>
-              </a:rPr>
-              <a:t>A physics-informed neural-network surrogate for diffusion-parameter inference</a:t>
-            </a:r>
-          </a:p>
-        </p:txBody>
-      </p:sp>
-      <p:pic>
-        <p:nvPicPr>
-          <p:cNvPr id="6" name=""/>
-          <p:cNvPicPr>
-            <a:picLocks xmlns:a="http://schemas.openxmlformats.org/drawingml/2006/main" noChangeAspect="1"/>
-          </p:cNvPicPr>
-          <p:nvPr/>
-        </p:nvPicPr>
-        <p:blipFill>
-          <a:blip xmlns:r="http://schemas.openxmlformats.org/officeDocument/2006/relationships" xmlns:a="http://schemas.openxmlformats.org/drawingml/2006/main" r:embed="Rf6fd7ae1559f4350"/>
-          <a:stretch xmlns:a="http://schemas.openxmlformats.org/drawingml/2006/main"/>
-        </p:blipFill>
-        <p:spPr>
-          <a:xfrm xmlns:a="http://schemas.openxmlformats.org/drawingml/2006/main">
-            <a:off x="2201647" y="3714750"/>
-            <a:ext cx="7617255" cy="1428750"/>
-          </a:xfrm>
-          <a:prstGeom xmlns:a="http://schemas.openxmlformats.org/drawingml/2006/main" prst="rect">
-            <a:avLst/>
-          </a:prstGeom>
-        </p:spPr>
-      </p:pic>
-      <p:sp>
-        <p:nvSpPr>
-          <p:cNvPr id="7" name="">
-            <a:extLst xmlns:a="http://schemas.openxmlformats.org/drawingml/2006/main">
-              <a:ext uri="{FF2B5EF4-FFF2-40B4-BE49-F238E27FC236}">
-                <a16:creationId xmlns:a16="http://schemas.microsoft.com/office/drawing/2014/main" id="{A91D2214-44ED-490B-9DFE-9AE2BC2281C9}"/>
-              </a:ext>
-            </a:extLst>
-          </p:cNvPr>
-          <p:cNvSpPr>
-            <a:spLocks xmlns:a="http://schemas.openxmlformats.org/drawingml/2006/main" noGrp="1"/>
-          </p:cNvSpPr>
-          <p:nvPr/>
-        </p:nvSpPr>
-        <p:spPr>
-          <a:xfrm xmlns:a="http://schemas.openxmlformats.org/drawingml/2006/main">
-            <a:off x="685800" y="5829300"/>
-            <a:ext cx="4000500" cy="209550"/>
-          </a:xfrm>
-          <a:prstGeom xmlns:a="http://schemas.openxmlformats.org/drawingml/2006/main" prst="rect">
-            <a:avLst/>
-          </a:prstGeom>
-          <a:solidFill xmlns:a="http://schemas.openxmlformats.org/drawingml/2006/main">
-            <a:srgbClr val="000000">
-              <a:alpha val="0"/>
-            </a:srgbClr>
-          </a:solidFill>
-          <a:ln xmlns:a="http://schemas.openxmlformats.org/drawingml/2006/main" w="0">
-            <a:solidFill>
-              <a:srgbClr val="000000">
-                <a:alpha val="0"/>
-              </a:srgbClr>
-            </a:solidFill>
-            <a:prstDash val="solid"/>
-          </a:ln>
-        </p:spPr>
-        <p:txBody>
-          <a:bodyPr xmlns:a="http://schemas.openxmlformats.org/drawingml/2006/main" lIns="0" tIns="0" rIns="0" bIns="0" anchor="t"/>
-          <a:lstStyle xmlns:a="http://schemas.openxmlformats.org/drawingml/2006/main"/>
-          <a:p xmlns:a="http://schemas.openxmlformats.org/drawingml/2006/main">
-            <a:pPr algn="l">
-              <a:defRPr sz="975" b="0">
-                <a:solidFill>
-                  <a:srgbClr val="6D6D6D"/>
-                </a:solidFill>
-                <a:latin typeface="Aptos"/>
-                <a:ea typeface="Aptos"/>
-                <a:cs typeface="Aptos"/>
-              </a:defRPr>
-            </a:pPr>
-            <a:r>
-              <a:rPr sz="975" b="0">
-                <a:solidFill>
-                  <a:srgbClr val="6D6D6D"/>
-                </a:solidFill>
-                <a:latin typeface="Aptos"/>
-                <a:ea typeface="Aptos"/>
-                <a:cs typeface="Aptos"/>
-              </a:rPr>
-              <a:t>Jack Jia | June 2026</a:t>
-            </a:r>
-          </a:p>
-        </p:txBody>
-      </p:sp>
-      <p:sp>
-        <p:nvSpPr>
-          <p:cNvPr id="8" name="">
-            <a:extLst xmlns:a="http://schemas.openxmlformats.org/drawingml/2006/main">
-              <a:ext uri="{FF2B5EF4-FFF2-40B4-BE49-F238E27FC236}">
-                <a16:creationId xmlns:a16="http://schemas.microsoft.com/office/drawing/2014/main" id="{B8810AC4-C042-4CC1-9F94-4EBC99B405CA}"/>
-              </a:ext>
-            </a:extLst>
-          </p:cNvPr>
-          <p:cNvSpPr>
-            <a:spLocks xmlns:a="http://schemas.openxmlformats.org/drawingml/2006/main" noGrp="1"/>
-          </p:cNvSpPr>
-          <p:nvPr/>
-        </p:nvSpPr>
-        <p:spPr>
-          <a:xfrm xmlns:a="http://schemas.openxmlformats.org/drawingml/2006/main">
-            <a:off x="7239000" y="5829300"/>
-            <a:ext cx="4095750" cy="209550"/>
-          </a:xfrm>
-          <a:prstGeom xmlns:a="http://schemas.openxmlformats.org/drawingml/2006/main" prst="rect">
-            <a:avLst/>
-          </a:prstGeom>
-          <a:solidFill xmlns:a="http://schemas.openxmlformats.org/drawingml/2006/main">
-            <a:srgbClr val="000000">
-              <a:alpha val="0"/>
-            </a:srgbClr>
-          </a:solidFill>
-          <a:ln xmlns:a="http://schemas.openxmlformats.org/drawingml/2006/main" w="0">
-            <a:solidFill>
-              <a:srgbClr val="000000">
-                <a:alpha val="0"/>
-              </a:srgbClr>
-            </a:solidFill>
-            <a:prstDash val="solid"/>
-          </a:ln>
-        </p:spPr>
-        <p:txBody>
-          <a:bodyPr xmlns:a="http://schemas.openxmlformats.org/drawingml/2006/main" lIns="0" tIns="0" rIns="0" bIns="0" anchor="t"/>
-          <a:lstStyle xmlns:a="http://schemas.openxmlformats.org/drawingml/2006/main"/>
-          <a:p xmlns:a="http://schemas.openxmlformats.org/drawingml/2006/main">
-            <a:pPr algn="r">
-              <a:defRPr sz="975" b="0">
-                <a:solidFill>
-                  <a:srgbClr val="6D6D6D"/>
-                </a:solidFill>
-                <a:latin typeface="Aptos"/>
-                <a:ea typeface="Aptos"/>
-                <a:cs typeface="Aptos"/>
-              </a:defRPr>
-            </a:pPr>
-            <a:r>
-              <a:rPr sz="975" b="0">
-                <a:solidFill>
-                  <a:srgbClr val="6D6D6D"/>
-                </a:solidFill>
-                <a:latin typeface="Aptos"/>
-                <a:ea typeface="Aptos"/>
-                <a:cs typeface="Aptos"/>
+                <a:latin typeface="Helvetica Neue"/>
               </a:rPr>
               <a:t>1D PNP PINN current-based inverse problem</a:t>
             </a:r>

</xml_diff>